<commit_message>
Topic 2: Catch-Up Day deck for Oct 26, Topic 2 retake for Nov 4, calendar re-planned around the Nov 3 test
- make_t2_cram.py: one 45-minute class with the starred parts of Lessons 1.2-1.4 and
  2.1-2.3, copied from the Lesson 1-2 decks (General, IEP, 504), with a timed plan,
  an exit check and tonight's test-style homework.
- make_t2_retake.py: the End of Topic 2 Assessment with new numbers (same 14 skills,
  order, letters and points), General / 504 / IEP plus keys, built with the
  assessment's own deck() and key().
- Calendar: Catch-Up Day Mon Oct 26, Lesson 3 Oct 27-28, Lesson 4 Oct 29 (finished
  Nov 4), review Nov 2, test Nov 3, retakes Nov 4; catch-up deck dates follow.

Co-Authored-By: Claude Opus 5.5 (1M context) <noreply@anthropic.com>
</commit_message>
<xml_diff>
--- a/IEP/t2-lesson2-vertical-horizontal-transformations-IEP-catchup.pptx
+++ b/IEP/t2-lesson2-vertical-horizontal-transformations-IEP-catchup.pptx
@@ -651,7 +651,7 @@
           <a:p>
             <a:r>
               <a:rPr lang="en-US" dirty="0"/>
-              <a:t>Class starts here on Tuesday, October 27.</a:t>
+              <a:t>Class starts here on an extra Lesson 2 day.</a:t>
             </a:r>
           </a:p>
         </p:txBody>
@@ -1291,7 +1291,7 @@
           <a:p>
             <a:r>
               <a:rPr lang="en-US" dirty="0"/>
-              <a:t>Class ends here on Tuesday, October 27.</a:t>
+              <a:t>Class ends here on an extra Lesson 2 day.</a:t>
             </a:r>
           </a:p>
         </p:txBody>
@@ -2220,7 +2220,7 @@
                 <a:latin typeface="Segoe UI"/>
                 <a:cs typeface="Segoe UI"/>
               </a:rPr>
-              <a:t xml:space="preserve">Adds a 15-minute Topic 1 Catch-Up (Lessons 5–6) each day · Day 1: Mon, Oct 26 · Day 2: Tue, Oct 27</a:t>
+              <a:t xml:space="preserve">Adds a 15-minute Topic 1 Catch-Up (Lessons 5–6) each day · Day 1: Mon, Oct 26 · Day 2: extra day</a:t>
             </a:r>
             <a:endParaRPr lang="en-US" sz="1650" dirty="0"/>
           </a:p>
@@ -15058,7 +15058,7 @@
         <p:spPr>
           <a:xfrm>
             <a:off x="685800" y="5253228"/>
-            <a:ext cx="10820095" cy="740664"/>
+            <a:ext cx="10820095" cy="1083564"/>
           </a:xfrm>
           <a:prstGeom prst="rect">
             <a:avLst/>
@@ -15087,7 +15087,7 @@
                 <a:latin typeface="Segoe UI"/>
                 <a:cs typeface="Segoe UI"/>
               </a:rPr>
-              <a:t xml:space="preserve">Next class: Tuesday, October 27. Start at the next slide, “Start: Tuesday, October 27.”</a:t>
+              <a:t xml:space="preserve">Next class: Tuesday, October 27. Lesson 3 starts: open the Lesson 3 deck. (Monday is the Catch-Up Day deck; use the next slide only if you get an extra Lesson 2 day.)</a:t>
             </a:r>
             <a:endParaRPr lang="en-US" sz="2250" dirty="0"/>
           </a:p>
@@ -15237,7 +15237,7 @@
                 <a:latin typeface="Segoe UI"/>
                 <a:cs typeface="Segoe UI"/>
               </a:rPr>
-              <a:t xml:space="preserve">Start: Tuesday, October 27</a:t>
+              <a:t xml:space="preserve">Start: an extra Lesson 2 day</a:t>
             </a:r>
             <a:endParaRPr lang="en-US" sz="8250" dirty="0"/>
           </a:p>
@@ -15387,7 +15387,7 @@
                 <a:latin typeface="Segoe UI"/>
                 <a:cs typeface="Segoe UI"/>
               </a:rPr>
-              <a:t xml:space="preserve">Day 2 · Bell Work · Review · Tue, Oct 27</a:t>
+              <a:t xml:space="preserve">Day 2 · Bell Work · Review · extra day</a:t>
             </a:r>
             <a:endParaRPr lang="en-US" sz="1200" dirty="0"/>
           </a:p>
@@ -18796,7 +18796,7 @@
                 <a:latin typeface="Segoe UI"/>
                 <a:cs typeface="Segoe UI"/>
               </a:rPr>
-              <a:t xml:space="preserve">Topic 1 Catch-Up · Tue, Oct 27 · about 15 minutes</a:t>
+              <a:t xml:space="preserve">Topic 1 Catch-Up · extra day · about 15 minutes</a:t>
             </a:r>
             <a:endParaRPr lang="en-US" sz="1200" dirty="0"/>
           </a:p>
@@ -28526,7 +28526,7 @@
                 <a:latin typeface="Segoe UI"/>
                 <a:cs typeface="Segoe UI"/>
               </a:rPr>
-              <a:t xml:space="preserve">Stop here: Tuesday, October 27</a:t>
+              <a:t xml:space="preserve">Stop here: an extra Lesson 2 day</a:t>
             </a:r>
             <a:endParaRPr lang="en-US" sz="8250" dirty="0"/>
           </a:p>
@@ -28541,7 +28541,7 @@
         <p:spPr>
           <a:xfrm>
             <a:off x="685800" y="5253228"/>
-            <a:ext cx="10820095" cy="740664"/>
+            <a:ext cx="10820095" cy="397764"/>
           </a:xfrm>
           <a:prstGeom prst="rect">
             <a:avLst/>
@@ -28570,7 +28570,7 @@
                 <a:latin typeface="Segoe UI"/>
                 <a:cs typeface="Segoe UI"/>
               </a:rPr>
-              <a:t xml:space="preserve">Next class: Wednesday, October 28. Lesson 3 starts: open the Lesson 3 deck. Tonight: the Lesson 2 quiz as homework.</a:t>
+              <a:t xml:space="preserve">Next class: Lesson 3. Open the Lesson 3 deck.</a:t>
             </a:r>
             <a:endParaRPr lang="en-US" sz="2250" dirty="0"/>
           </a:p>

</xml_diff>